<commit_message>
Rebrand demo initiative from Project CLARITY to Project Qlarity
Rename the flagship demo initiative to "Project Qlarity" (a Qlik + Clarity
play) across all generators and source content, then regenerate the decks,
documents, and demo scripts so the deliverables match.

- Display name only: "Project CLARITY"/"CLARITY" -> "Project Qlarity"/"Qlarity"
- Kept the PROJ-CLARITY-2025 document ID and Business Case filename intact
- Left code identifiers (clarityContext/projClarity) and the common word
  "clarity" untouched
- Regenerated 3 PPTX decks, the DOCX docs, demo scripts, and the glossary

Co-Authored-By: Claude Opus 4.8 <noreply@anthropic.com>
</commit_message>
<xml_diff>
--- a/MCG_Company_Profile_Data_Quality.pptx
+++ b/MCG_Company_Profile_Data_Quality.pptx
@@ -2086,6 +2086,59 @@
         </p:nvSpPr>
         <p:spPr>
           <a:xfrm>
+            <a:off x="731520" y="4846320"/>
+            <a:ext cx="10698480" cy="457200"/>
+          </a:xfrm>
+          <a:prstGeom prst="rect">
+            <a:avLst/>
+          </a:prstGeom>
+          <a:noFill/>
+          <a:ln/>
+        </p:spPr>
+        <p:txBody>
+          <a:bodyPr wrap="square" rtlCol="0" anchor="ctr"/>
+          <a:lstStyle/>
+          <a:p>
+            <a:pPr indent="0" marL="0">
+              <a:buNone/>
+            </a:pPr>
+            <a:r>
+              <a:rPr lang="en-US" sz="1600" b="1" dirty="0">
+                <a:solidFill>
+                  <a:srgbClr val="0D7C8F"/>
+                </a:solidFill>
+                <a:latin typeface="Calibri" pitchFamily="34" charset="0"/>
+                <a:ea typeface="Calibri" pitchFamily="34" charset="-122"/>
+                <a:cs typeface="Calibri" pitchFamily="34" charset="-120"/>
+              </a:rPr>
+              <a:t>PROJECT Qlarity</a:t>
+            </a:r>
+            <a:pPr indent="0" marL="0">
+              <a:buNone/>
+            </a:pPr>
+            <a:r>
+              <a:rPr lang="en-US" sz="1400" dirty="0">
+                <a:solidFill>
+                  <a:srgbClr val="6B7280"/>
+                </a:solidFill>
+                <a:latin typeface="Calibri" pitchFamily="34" charset="0"/>
+                <a:ea typeface="Calibri" pitchFamily="34" charset="-122"/>
+                <a:cs typeface="Calibri" pitchFamily="34" charset="-120"/>
+              </a:rPr>
+              <a:t>   Connected Logistics, Analytics &amp; Real-time Intelligence Technology</a:t>
+            </a:r>
+            <a:endParaRPr lang="en-US" sz="1600" dirty="0"/>
+          </a:p>
+        </p:txBody>
+      </p:sp>
+      <p:sp>
+        <p:nvSpPr>
+          <p:cNvPr id="9" name="Text 7"/>
+          <p:cNvSpPr/>
+          <p:nvPr/>
+        </p:nvSpPr>
+        <p:spPr>
+          <a:xfrm>
             <a:off x="731520" y="5943600"/>
             <a:ext cx="3657600" cy="365760"/>
           </a:xfrm>
@@ -2202,7 +2255,7 @@
                 <a:ea typeface="Calibri" pitchFamily="34" charset="-122"/>
                 <a:cs typeface="Calibri" pitchFamily="34" charset="-120"/>
               </a:rPr>
-              <a:t>Project CLARITY</a:t>
+              <a:t>Project Qlarity</a:t>
             </a:r>
             <a:endParaRPr lang="en-US" sz="4000" dirty="0"/>
           </a:p>
@@ -2371,7 +2424,7 @@
                 <a:ea typeface="Calibri" pitchFamily="34" charset="-122"/>
                 <a:cs typeface="Calibri" pitchFamily="34" charset="-120"/>
               </a:rPr>
-              <a:t>Meridian Commerce Group  •  Confidential</a:t>
+              <a:t>Project Qlarity  •  Meridian Commerce Group  •  Confidential</a:t>
             </a:r>
             <a:endParaRPr lang="en-US" sz="900" dirty="0"/>
           </a:p>
@@ -2469,7 +2522,7 @@
                 <a:ea typeface="Calibri" pitchFamily="34" charset="-122"/>
                 <a:cs typeface="Calibri" pitchFamily="34" charset="-120"/>
               </a:rPr>
-              <a:t>Project CLARITY — Qlik Platform Solution</a:t>
+              <a:t>Project Qlarity — Qlik Platform Solution</a:t>
             </a:r>
             <a:endParaRPr lang="en-US" sz="2600" dirty="0"/>
           </a:p>
@@ -3966,7 +4019,7 @@
                 <a:ea typeface="Calibri" pitchFamily="34" charset="-122"/>
                 <a:cs typeface="Calibri" pitchFamily="34" charset="-120"/>
               </a:rPr>
-              <a:t>Meridian Commerce Group  •  Confidential</a:t>
+              <a:t>Project Qlarity  •  Meridian Commerce Group  •  Confidential</a:t>
             </a:r>
             <a:endParaRPr lang="en-US" sz="900" dirty="0"/>
           </a:p>
@@ -4961,7 +5014,7 @@
                 <a:ea typeface="Calibri" pitchFamily="34" charset="-122"/>
                 <a:cs typeface="Calibri" pitchFamily="34" charset="-120"/>
               </a:rPr>
-              <a:t>Meridian Commerce Group  •  Confidential</a:t>
+              <a:t>Project Qlarity  •  Meridian Commerce Group  •  Confidential</a:t>
             </a:r>
             <a:endParaRPr lang="en-US" sz="900" dirty="0"/>
           </a:p>
@@ -8106,7 +8159,7 @@
                 <a:ea typeface="Calibri" pitchFamily="34" charset="-122"/>
                 <a:cs typeface="Calibri" pitchFamily="34" charset="-120"/>
               </a:rPr>
-              <a:t>Meridian Commerce Group  •  Confidential</a:t>
+              <a:t>Project Qlarity  •  Meridian Commerce Group  •  Confidential</a:t>
             </a:r>
             <a:endParaRPr lang="en-US" sz="900" dirty="0"/>
           </a:p>
@@ -9699,7 +9752,7 @@
                 <a:ea typeface="Calibri" pitchFamily="34" charset="-122"/>
                 <a:cs typeface="Calibri" pitchFamily="34" charset="-120"/>
               </a:rPr>
-              <a:t>Meridian Commerce Group  •  Confidential</a:t>
+              <a:t>Project Qlarity  •  Meridian Commerce Group  •  Confidential</a:t>
             </a:r>
             <a:endParaRPr lang="en-US" sz="900" dirty="0"/>
           </a:p>
@@ -10461,7 +10514,7 @@
                 <a:ea typeface="Calibri" pitchFamily="34" charset="-122"/>
                 <a:cs typeface="Calibri" pitchFamily="34" charset="-120"/>
               </a:rPr>
-              <a:t>Meridian Commerce Group  •  Confidential</a:t>
+              <a:t>Project Qlarity  •  Meridian Commerce Group  •  Confidential</a:t>
             </a:r>
             <a:endParaRPr lang="en-US" sz="900" dirty="0"/>
           </a:p>
@@ -13120,7 +13173,7 @@
                 <a:ea typeface="Calibri" pitchFamily="34" charset="-122"/>
                 <a:cs typeface="Calibri" pitchFamily="34" charset="-120"/>
               </a:rPr>
-              <a:t>Meridian Commerce Group  •  Confidential</a:t>
+              <a:t>Project Qlarity  •  Meridian Commerce Group  •  Confidential</a:t>
             </a:r>
             <a:endParaRPr lang="en-US" sz="900" dirty="0"/>
           </a:p>
@@ -14016,7 +14069,7 @@
                 <a:ea typeface="Calibri" pitchFamily="34" charset="-122"/>
                 <a:cs typeface="Calibri" pitchFamily="34" charset="-120"/>
               </a:rPr>
-              <a:t>Meridian Commerce Group  •  Confidential</a:t>
+              <a:t>Project Qlarity  •  Meridian Commerce Group  •  Confidential</a:t>
             </a:r>
             <a:endParaRPr lang="en-US" sz="900" dirty="0"/>
           </a:p>

</xml_diff>